<commit_message>
Help image for the BridgeTimers added
</commit_message>
<xml_diff>
--- a/HelpSystem/Images/TimerSettings.pptx
+++ b/HelpSystem/Images/TimerSettings.pptx
@@ -198,7 +198,7 @@
           <a:p>
             <a:fld id="{FE48C782-22FD-4F3A-B476-61B759A9EBB9}" type="datetimeFigureOut">
               <a:rPr lang="da-DK" smtClean="0"/>
-              <a:t>30-06-2026</a:t>
+              <a:t>11-10-2026</a:t>
             </a:fld>
             <a:endParaRPr lang="da-DK"/>
           </a:p>
@@ -596,7 +596,7 @@
           <a:p>
             <a:fld id="{7F7C35B5-416F-4C6A-A7BA-3025FC0120D2}" type="datetimeFigureOut">
               <a:rPr lang="da-DK" smtClean="0"/>
-              <a:t>30-06-2026</a:t>
+              <a:t>11-10-2026</a:t>
             </a:fld>
             <a:endParaRPr lang="da-DK"/>
           </a:p>
@@ -766,7 +766,7 @@
           <a:p>
             <a:fld id="{7F7C35B5-416F-4C6A-A7BA-3025FC0120D2}" type="datetimeFigureOut">
               <a:rPr lang="da-DK" smtClean="0"/>
-              <a:t>30-06-2026</a:t>
+              <a:t>11-10-2026</a:t>
             </a:fld>
             <a:endParaRPr lang="da-DK"/>
           </a:p>
@@ -946,7 +946,7 @@
           <a:p>
             <a:fld id="{7F7C35B5-416F-4C6A-A7BA-3025FC0120D2}" type="datetimeFigureOut">
               <a:rPr lang="da-DK" smtClean="0"/>
-              <a:t>30-06-2026</a:t>
+              <a:t>11-10-2026</a:t>
             </a:fld>
             <a:endParaRPr lang="da-DK"/>
           </a:p>
@@ -1116,7 +1116,7 @@
           <a:p>
             <a:fld id="{7F7C35B5-416F-4C6A-A7BA-3025FC0120D2}" type="datetimeFigureOut">
               <a:rPr lang="da-DK" smtClean="0"/>
-              <a:t>30-06-2026</a:t>
+              <a:t>11-10-2026</a:t>
             </a:fld>
             <a:endParaRPr lang="da-DK"/>
           </a:p>
@@ -1362,7 +1362,7 @@
           <a:p>
             <a:fld id="{7F7C35B5-416F-4C6A-A7BA-3025FC0120D2}" type="datetimeFigureOut">
               <a:rPr lang="da-DK" smtClean="0"/>
-              <a:t>30-06-2026</a:t>
+              <a:t>11-10-2026</a:t>
             </a:fld>
             <a:endParaRPr lang="da-DK"/>
           </a:p>
@@ -1594,7 +1594,7 @@
           <a:p>
             <a:fld id="{7F7C35B5-416F-4C6A-A7BA-3025FC0120D2}" type="datetimeFigureOut">
               <a:rPr lang="da-DK" smtClean="0"/>
-              <a:t>30-06-2026</a:t>
+              <a:t>11-10-2026</a:t>
             </a:fld>
             <a:endParaRPr lang="da-DK"/>
           </a:p>
@@ -1961,7 +1961,7 @@
           <a:p>
             <a:fld id="{7F7C35B5-416F-4C6A-A7BA-3025FC0120D2}" type="datetimeFigureOut">
               <a:rPr lang="da-DK" smtClean="0"/>
-              <a:t>30-06-2026</a:t>
+              <a:t>11-10-2026</a:t>
             </a:fld>
             <a:endParaRPr lang="da-DK"/>
           </a:p>
@@ -2079,7 +2079,7 @@
           <a:p>
             <a:fld id="{7F7C35B5-416F-4C6A-A7BA-3025FC0120D2}" type="datetimeFigureOut">
               <a:rPr lang="da-DK" smtClean="0"/>
-              <a:t>30-06-2026</a:t>
+              <a:t>11-10-2026</a:t>
             </a:fld>
             <a:endParaRPr lang="da-DK"/>
           </a:p>
@@ -2174,7 +2174,7 @@
           <a:p>
             <a:fld id="{7F7C35B5-416F-4C6A-A7BA-3025FC0120D2}" type="datetimeFigureOut">
               <a:rPr lang="da-DK" smtClean="0"/>
-              <a:t>30-06-2026</a:t>
+              <a:t>11-10-2026</a:t>
             </a:fld>
             <a:endParaRPr lang="da-DK"/>
           </a:p>
@@ -2451,7 +2451,7 @@
           <a:p>
             <a:fld id="{7F7C35B5-416F-4C6A-A7BA-3025FC0120D2}" type="datetimeFigureOut">
               <a:rPr lang="da-DK" smtClean="0"/>
-              <a:t>30-06-2026</a:t>
+              <a:t>11-10-2026</a:t>
             </a:fld>
             <a:endParaRPr lang="da-DK"/>
           </a:p>
@@ -2708,7 +2708,7 @@
           <a:p>
             <a:fld id="{7F7C35B5-416F-4C6A-A7BA-3025FC0120D2}" type="datetimeFigureOut">
               <a:rPr lang="da-DK" smtClean="0"/>
-              <a:t>30-06-2026</a:t>
+              <a:t>11-10-2026</a:t>
             </a:fld>
             <a:endParaRPr lang="da-DK"/>
           </a:p>
@@ -2921,7 +2921,7 @@
           <a:p>
             <a:fld id="{7F7C35B5-416F-4C6A-A7BA-3025FC0120D2}" type="datetimeFigureOut">
               <a:rPr lang="da-DK" smtClean="0"/>
-              <a:t>30-06-2026</a:t>
+              <a:t>11-10-2026</a:t>
             </a:fld>
             <a:endParaRPr lang="da-DK"/>
           </a:p>
@@ -3652,7 +3652,7 @@
         </p:nvSpPr>
         <p:spPr>
           <a:xfrm>
-            <a:off x="181717" y="8753936"/>
+            <a:off x="191445" y="6652761"/>
             <a:ext cx="6835877" cy="5509200"/>
           </a:xfrm>
           <a:prstGeom prst="rect">
@@ -3841,12 +3841,8 @@
               </a:spcBef>
             </a:pPr>
             <a:r>
-              <a:rPr lang="da-DK" sz="1200" b="1"/>
-              <a:t>Pause </a:t>
-            </a:r>
-            <a:r>
               <a:rPr lang="da-DK" sz="1200" b="1" dirty="0"/>
-              <a:t>meddelelse og Slut hilsner;</a:t>
+              <a:t>Pause meddelelse og Slut hilsner;</a:t>
             </a:r>
           </a:p>
           <a:p>
@@ -3879,7 +3875,7 @@
         </p:blipFill>
         <p:spPr>
           <a:xfrm>
-            <a:off x="363489" y="2293619"/>
+            <a:off x="373217" y="192444"/>
             <a:ext cx="6029801" cy="6401753"/>
           </a:xfrm>
           <a:prstGeom prst="rect">

</xml_diff>